<commit_message>
Bitácora de IA como documento de entrega y URL publicada en el informe y la presentación
- docs/proyecto-final/Bitacora_IA_Proyecto_Final (.docx y .pdf).
- Informe técnico y presentación con https://manosdeloriente.infinityfreeapp.com.
- Tablas de los documentos con anchos de columna fijos.

Co-Authored-By: Claude Opus 5.5 <noreply@anthropic.com>
</commit_message>
<xml_diff>
--- a/docs/proyecto-final/Presentacion_Proyecto_Final.pptx
+++ b/docs/proyecto-final/Presentacion_Proyecto_Final.pptx
@@ -2306,7 +2306,28 @@
                 <a:ea typeface="Calibri" pitchFamily="34" charset="-122"/>
                 <a:cs typeface="Calibri" pitchFamily="34" charset="-120"/>
               </a:rPr>
-              <a:t>Un script arma htdocs, el .zip y el .sql para phpMyAdmin</a:t>
+              <a:t>https://manosdeloriente.infinityfreeapp.com</a:t>
+            </a:r>
+            <a:endParaRPr lang="en-US" sz="1700" dirty="0"/>
+          </a:p>
+          <a:p>
+            <a:pPr marL="342900" indent="-342900">
+              <a:spcAft>
+                <a:spcPts val="1000"/>
+              </a:spcAft>
+              <a:buSzPct val="100000"/>
+              <a:buChar char="●"/>
+            </a:pPr>
+            <a:r>
+              <a:rPr lang="en-US" sz="1700" dirty="0">
+                <a:solidFill>
+                  <a:srgbClr val="2E2A30"/>
+                </a:solidFill>
+                <a:latin typeface="Calibri" pitchFamily="34" charset="0"/>
+                <a:ea typeface="Calibri" pitchFamily="34" charset="-122"/>
+                <a:cs typeface="Calibri" pitchFamily="34" charset="-120"/>
+              </a:rPr>
+              <a:t>Un script arma el paquete; subido por FTP (95 archivos)</a:t>
             </a:r>
             <a:endParaRPr lang="en-US" sz="1700" dirty="0"/>
           </a:p>
@@ -3411,6 +3432,27 @@
         <p:txBody>
           <a:bodyPr wrap="square" rtlCol="0" anchor="t"/>
           <a:lstStyle/>
+          <a:p>
+            <a:pPr marL="342900" indent="-342900">
+              <a:spcAft>
+                <a:spcPts val="1200"/>
+              </a:spcAft>
+              <a:buSzPct val="100000"/>
+              <a:buChar char="✔"/>
+            </a:pPr>
+            <a:r>
+              <a:rPr lang="en-US" sz="2000" dirty="0">
+                <a:solidFill>
+                  <a:srgbClr val="2E2A30"/>
+                </a:solidFill>
+                <a:latin typeface="Calibri" pitchFamily="34" charset="0"/>
+                <a:ea typeface="Calibri" pitchFamily="34" charset="-122"/>
+                <a:cs typeface="Calibri" pitchFamily="34" charset="-120"/>
+              </a:rPr>
+              <a:t>Sitio: manosdeloriente.infinityfreeapp.com</a:t>
+            </a:r>
+            <a:endParaRPr lang="en-US" sz="2000" dirty="0"/>
+          </a:p>
           <a:p>
             <a:pPr marL="342900" indent="-342900">
               <a:spcAft>

</xml_diff>